<commit_message>
Refactor input AST and enhance testing documentation
- Updated the input AST in `input_ast.json` to include a new helper function and modified the compute function with additional variables and logic.
- Added new test images for lexer and parser results in the `report/figures` directory.
- Revised the report PDF to reflect changes in the testing sections, including integration tests and results.
- Enhanced the LaTeX report with detailed integration testing code and descriptions for better clarity and documentation.
</commit_message>
<xml_diff>
--- a/TJ_CompileTheory_汇报PPT.pptx
+++ b/TJ_CompileTheory_汇报PPT.pptx
@@ -5065,14 +5065,14 @@
           <p:nvPr>
             <p:extLst>
               <p:ext uri="{D42A27DB-BD31-4B8C-83A1-F6EECF244321}">
-                <p14:modId xmlns:p14="http://schemas.microsoft.com/office/powerpoint/2010/main" val="3719329083"/>
+                <p14:modId xmlns:p14="http://schemas.microsoft.com/office/powerpoint/2010/main" val="1507270237"/>
               </p:ext>
             </p:extLst>
           </p:nvPr>
         </p:nvGraphicFramePr>
         <p:xfrm>
-          <a:off x="502920" y="1570867"/>
-          <a:ext cx="5677000" cy="2138680"/>
+          <a:off x="502919" y="1570867"/>
+          <a:ext cx="9145782" cy="1577317"/>
         </p:xfrm>
         <a:graphic>
           <a:graphicData uri="http://schemas.openxmlformats.org/drawingml/2006/table">
@@ -5081,14 +5081,14 @@
                 <a:tableStyleId>{5C22544A-7EE6-4342-B048-85BDC9FD1C3A}</a:tableStyleId>
               </a:tblPr>
               <a:tblGrid>
-                <a:gridCol w="2838500">
+                <a:gridCol w="4572891">
                   <a:extLst>
                     <a:ext uri="{9D8B030D-6E8A-4147-A177-3AD203B41FA5}">
                       <a16:colId xmlns:a16="http://schemas.microsoft.com/office/drawing/2014/main" val="2024018592"/>
                     </a:ext>
                   </a:extLst>
                 </a:gridCol>
-                <a:gridCol w="2838500">
+                <a:gridCol w="4572891">
                   <a:extLst>
                     <a:ext uri="{9D8B030D-6E8A-4147-A177-3AD203B41FA5}">
                       <a16:colId xmlns:a16="http://schemas.microsoft.com/office/drawing/2014/main" val="117041901"/>
@@ -5096,7 +5096,7 @@
                   </a:extLst>
                 </a:gridCol>
               </a:tblGrid>
-              <a:tr h="370840">
+              <a:tr h="266835">
                 <a:tc>
                   <a:txBody>
                     <a:bodyPr/>
@@ -5129,7 +5129,7 @@
                   </a:ext>
                 </a:extLst>
               </a:tr>
-              <a:tr h="370840">
+              <a:tr h="479354">
                 <a:tc>
                   <a:txBody>
                     <a:bodyPr/>
@@ -5217,44 +5217,9 @@
                             <a:srgbClr val="1F2933"/>
                           </a:solidFill>
                         </a:rPr>
-                        <a:t>个文件输出</a:t>
-                      </a:r>
-                      <a:endParaRPr lang="en-US" altLang="zh-CN" sz="1400" dirty="0">
-                        <a:solidFill>
-                          <a:srgbClr val="1F2933"/>
-                        </a:solidFill>
-                      </a:endParaRPr>
-                    </a:p>
-                    <a:p>
-                      <a:pPr marL="0" marR="0" lvl="0" indent="0" algn="l" defTabSz="914400" rtl="0" eaLnBrk="1" fontAlgn="auto" latinLnBrk="0" hangingPunct="1">
-                        <a:lnSpc>
-                          <a:spcPct val="100000"/>
-                        </a:lnSpc>
-                        <a:spcBef>
-                          <a:spcPts val="0"/>
-                        </a:spcBef>
-                        <a:spcAft>
-                          <a:spcPts val="0"/>
-                        </a:spcAft>
-                        <a:buClrTx/>
-                        <a:buSzTx/>
-                        <a:buFontTx/>
-                        <a:buNone/>
-                        <a:tabLst/>
-                        <a:defRPr/>
-                      </a:pPr>
-                      <a:r>
-                        <a:rPr lang="en-US" altLang="zh-CN" sz="1400" dirty="0" err="1">
-                          <a:solidFill>
-                            <a:srgbClr val="1F2933"/>
-                          </a:solidFill>
-                        </a:rPr>
-                        <a:t>集成测试</a:t>
+                        <a:t>个文件输出集成测试</a:t>
                       </a:r>
                       <a:endParaRPr lang="en-US" altLang="zh-CN" sz="1400" dirty="0"/>
-                    </a:p>
-                    <a:p>
-                      <a:endParaRPr lang="zh-CN" altLang="en-US" sz="1400" dirty="0"/>
                     </a:p>
                   </a:txBody>
                   <a:tcPr/>
@@ -5265,7 +5230,7 @@
                   </a:ext>
                 </a:extLst>
               </a:tr>
-              <a:tr h="370840">
+              <a:tr h="339543">
                 <a:tc>
                   <a:txBody>
                     <a:bodyPr/>
@@ -5353,39 +5318,7 @@
                             <a:srgbClr val="1F2933"/>
                           </a:solidFill>
                         </a:rPr>
-                        <a:t>个文件输出</a:t>
-                      </a:r>
-                      <a:endParaRPr lang="en-US" altLang="zh-CN" sz="1400" dirty="0">
-                        <a:solidFill>
-                          <a:srgbClr val="1F2933"/>
-                        </a:solidFill>
-                      </a:endParaRPr>
-                    </a:p>
-                    <a:p>
-                      <a:pPr marL="0" marR="0" lvl="0" indent="0" algn="l" defTabSz="914400" rtl="0" eaLnBrk="1" fontAlgn="auto" latinLnBrk="0" hangingPunct="1">
-                        <a:lnSpc>
-                          <a:spcPct val="100000"/>
-                        </a:lnSpc>
-                        <a:spcBef>
-                          <a:spcPts val="0"/>
-                        </a:spcBef>
-                        <a:spcAft>
-                          <a:spcPts val="0"/>
-                        </a:spcAft>
-                        <a:buClrTx/>
-                        <a:buSzTx/>
-                        <a:buFontTx/>
-                        <a:buNone/>
-                        <a:tabLst/>
-                        <a:defRPr/>
-                      </a:pPr>
-                      <a:r>
-                        <a:rPr lang="en-US" altLang="zh-CN" sz="1400" dirty="0" err="1">
-                          <a:solidFill>
-                            <a:srgbClr val="1F2933"/>
-                          </a:solidFill>
-                        </a:rPr>
-                        <a:t>集成测试</a:t>
+                        <a:t>个文件输出集成测试</a:t>
                       </a:r>
                       <a:endParaRPr lang="en-US" altLang="zh-CN" sz="1400" dirty="0"/>
                     </a:p>
@@ -5398,7 +5331,7 @@
                   </a:ext>
                 </a:extLst>
               </a:tr>
-              <a:tr h="370840">
+              <a:tr h="453620">
                 <a:tc>
                   <a:txBody>
                     <a:bodyPr/>
@@ -5429,26 +5362,6 @@
                         </a:rPr>
                         <a:t>Easy_Server</a:t>
                       </a:r>
-                      <a:endParaRPr lang="en-US" altLang="zh-CN" sz="1400" dirty="0"/>
-                    </a:p>
-                    <a:p>
-                      <a:pPr marL="0" marR="0" lvl="0" indent="0" algn="l" defTabSz="914400" rtl="0" eaLnBrk="1" fontAlgn="auto" latinLnBrk="0" hangingPunct="1">
-                        <a:lnSpc>
-                          <a:spcPct val="100000"/>
-                        </a:lnSpc>
-                        <a:spcBef>
-                          <a:spcPts val="0"/>
-                        </a:spcBef>
-                        <a:spcAft>
-                          <a:spcPts val="0"/>
-                        </a:spcAft>
-                        <a:buClrTx/>
-                        <a:buSzTx/>
-                        <a:buFontTx/>
-                        <a:buNone/>
-                        <a:tabLst/>
-                        <a:defRPr/>
-                      </a:pPr>
                       <a:endParaRPr lang="en-US" altLang="zh-CN" sz="1400" dirty="0"/>
                     </a:p>
                   </a:txBody>
@@ -5517,8 +5430,8 @@
         </p:blipFill>
         <p:spPr>
           <a:xfrm>
-            <a:off x="7394953" y="716080"/>
-            <a:ext cx="3650105" cy="2579868"/>
+            <a:off x="502920" y="3356595"/>
+            <a:ext cx="4098768" cy="2896980"/>
           </a:xfrm>
           <a:prstGeom prst="rect">
             <a:avLst/>
@@ -5539,7 +5452,7 @@
         </p:nvSpPr>
         <p:spPr>
           <a:xfrm>
-            <a:off x="11188885" y="1023415"/>
+            <a:off x="4601688" y="3832446"/>
             <a:ext cx="277691" cy="1668041"/>
           </a:xfrm>
           <a:prstGeom prst="rect">
@@ -5589,8 +5502,8 @@
         </p:blipFill>
         <p:spPr>
           <a:xfrm>
-            <a:off x="7394953" y="3562052"/>
-            <a:ext cx="4463768" cy="2765596"/>
+            <a:off x="6533992" y="3356595"/>
+            <a:ext cx="4675826" cy="2896980"/>
           </a:xfrm>
           <a:prstGeom prst="rect">
             <a:avLst/>
@@ -5611,7 +5524,7 @@
         </p:nvSpPr>
         <p:spPr>
           <a:xfrm>
-            <a:off x="11858721" y="3972454"/>
+            <a:off x="11209818" y="3818359"/>
             <a:ext cx="277691" cy="1668041"/>
           </a:xfrm>
           <a:prstGeom prst="rect">
@@ -8173,12 +8086,12 @@
               <a:buNone/>
             </a:pPr>
             <a:r>
-              <a:rPr lang="en-US" sz="1050" dirty="0">
+              <a:rPr lang="en-US" sz="1050" dirty="0" err="1">
                 <a:solidFill>
                   <a:srgbClr val="1F2933"/>
                 </a:solidFill>
               </a:rPr>
-              <a:t>完成原型</a:t>
+              <a:t>完成</a:t>
             </a:r>
             <a:endParaRPr lang="en-US" sz="1050" dirty="0"/>
           </a:p>
@@ -9161,6 +9074,508 @@
           </a:p>
         </p:txBody>
       </p:sp>
+      <p:graphicFrame>
+        <p:nvGraphicFramePr>
+          <p:cNvPr id="14" name="表格 13">
+            <a:extLst>
+              <a:ext uri="{FF2B5EF4-FFF2-40B4-BE49-F238E27FC236}">
+                <a16:creationId xmlns:a16="http://schemas.microsoft.com/office/drawing/2014/main" id="{B18ACFD9-26E2-9157-1FAA-AE82D15EAB8E}"/>
+              </a:ext>
+            </a:extLst>
+          </p:cNvPr>
+          <p:cNvGraphicFramePr>
+            <a:graphicFrameLocks noGrp="1"/>
+          </p:cNvGraphicFramePr>
+          <p:nvPr>
+            <p:extLst>
+              <p:ext uri="{D42A27DB-BD31-4B8C-83A1-F6EECF244321}">
+                <p14:modId xmlns:p14="http://schemas.microsoft.com/office/powerpoint/2010/main" val="439962554"/>
+              </p:ext>
+            </p:extLst>
+          </p:nvPr>
+        </p:nvGraphicFramePr>
+        <p:xfrm>
+          <a:off x="738645" y="4425330"/>
+          <a:ext cx="5109952" cy="1622496"/>
+        </p:xfrm>
+        <a:graphic>
+          <a:graphicData uri="http://schemas.openxmlformats.org/drawingml/2006/table">
+            <a:tbl>
+              <a:tblPr firstRow="1" bandRow="1">
+                <a:tableStyleId>{69012ECD-51FC-41F1-AA8D-1B2483CD663E}</a:tableStyleId>
+              </a:tblPr>
+              <a:tblGrid>
+                <a:gridCol w="2554976">
+                  <a:extLst>
+                    <a:ext uri="{9D8B030D-6E8A-4147-A177-3AD203B41FA5}">
+                      <a16:colId xmlns:a16="http://schemas.microsoft.com/office/drawing/2014/main" val="2975816472"/>
+                    </a:ext>
+                  </a:extLst>
+                </a:gridCol>
+                <a:gridCol w="2554976">
+                  <a:extLst>
+                    <a:ext uri="{9D8B030D-6E8A-4147-A177-3AD203B41FA5}">
+                      <a16:colId xmlns:a16="http://schemas.microsoft.com/office/drawing/2014/main" val="3015388845"/>
+                    </a:ext>
+                  </a:extLst>
+                </a:gridCol>
+              </a:tblGrid>
+              <a:tr h="405624">
+                <a:tc>
+                  <a:txBody>
+                    <a:bodyPr/>
+                    <a:lstStyle/>
+                    <a:p>
+                      <a:r>
+                        <a:rPr lang="zh-CN" altLang="en-US" dirty="0"/>
+                        <a:t>小组成员</a:t>
+                      </a:r>
+                    </a:p>
+                  </a:txBody>
+                  <a:tcPr>
+                    <a:lnL w="12700" cap="flat" cmpd="sng" algn="ctr">
+                      <a:solidFill>
+                        <a:schemeClr val="tx1"/>
+                      </a:solidFill>
+                      <a:prstDash val="solid"/>
+                      <a:round/>
+                      <a:headEnd type="none" w="med" len="med"/>
+                      <a:tailEnd type="none" w="med" len="med"/>
+                    </a:lnL>
+                    <a:lnR w="12700" cap="flat" cmpd="sng" algn="ctr">
+                      <a:solidFill>
+                        <a:schemeClr val="tx1"/>
+                      </a:solidFill>
+                      <a:prstDash val="solid"/>
+                      <a:round/>
+                      <a:headEnd type="none" w="med" len="med"/>
+                      <a:tailEnd type="none" w="med" len="med"/>
+                    </a:lnR>
+                    <a:lnT w="12700" cap="flat" cmpd="sng" algn="ctr">
+                      <a:solidFill>
+                        <a:schemeClr val="tx1"/>
+                      </a:solidFill>
+                      <a:prstDash val="solid"/>
+                      <a:round/>
+                      <a:headEnd type="none" w="med" len="med"/>
+                      <a:tailEnd type="none" w="med" len="med"/>
+                    </a:lnT>
+                    <a:lnB w="12700" cap="flat" cmpd="sng" algn="ctr">
+                      <a:solidFill>
+                        <a:schemeClr val="tx1"/>
+                      </a:solidFill>
+                      <a:prstDash val="solid"/>
+                      <a:round/>
+                      <a:headEnd type="none" w="med" len="med"/>
+                      <a:tailEnd type="none" w="med" len="med"/>
+                    </a:lnB>
+                  </a:tcPr>
+                </a:tc>
+                <a:tc>
+                  <a:txBody>
+                    <a:bodyPr/>
+                    <a:lstStyle/>
+                    <a:p>
+                      <a:r>
+                        <a:rPr lang="zh-CN" altLang="en-US" dirty="0"/>
+                        <a:t>分工内容</a:t>
+                      </a:r>
+                    </a:p>
+                  </a:txBody>
+                  <a:tcPr>
+                    <a:lnL w="12700" cap="flat" cmpd="sng" algn="ctr">
+                      <a:solidFill>
+                        <a:schemeClr val="tx1"/>
+                      </a:solidFill>
+                      <a:prstDash val="solid"/>
+                      <a:round/>
+                      <a:headEnd type="none" w="med" len="med"/>
+                      <a:tailEnd type="none" w="med" len="med"/>
+                    </a:lnL>
+                    <a:lnR w="12700" cap="flat" cmpd="sng" algn="ctr">
+                      <a:solidFill>
+                        <a:schemeClr val="tx1"/>
+                      </a:solidFill>
+                      <a:prstDash val="solid"/>
+                      <a:round/>
+                      <a:headEnd type="none" w="med" len="med"/>
+                      <a:tailEnd type="none" w="med" len="med"/>
+                    </a:lnR>
+                    <a:lnT w="12700" cap="flat" cmpd="sng" algn="ctr">
+                      <a:solidFill>
+                        <a:schemeClr val="tx1"/>
+                      </a:solidFill>
+                      <a:prstDash val="solid"/>
+                      <a:round/>
+                      <a:headEnd type="none" w="med" len="med"/>
+                      <a:tailEnd type="none" w="med" len="med"/>
+                    </a:lnT>
+                    <a:lnB w="12700" cap="flat" cmpd="sng" algn="ctr">
+                      <a:solidFill>
+                        <a:schemeClr val="tx1"/>
+                      </a:solidFill>
+                      <a:prstDash val="solid"/>
+                      <a:round/>
+                      <a:headEnd type="none" w="med" len="med"/>
+                      <a:tailEnd type="none" w="med" len="med"/>
+                    </a:lnB>
+                  </a:tcPr>
+                </a:tc>
+                <a:extLst>
+                  <a:ext uri="{0D108BD9-81ED-4DB2-BD59-A6C34878D82A}">
+                    <a16:rowId xmlns:a16="http://schemas.microsoft.com/office/drawing/2014/main" val="3085232785"/>
+                  </a:ext>
+                </a:extLst>
+              </a:tr>
+              <a:tr h="405624">
+                <a:tc>
+                  <a:txBody>
+                    <a:bodyPr/>
+                    <a:lstStyle/>
+                    <a:p>
+                      <a:r>
+                        <a:rPr lang="zh-CN" altLang="en-US" dirty="0"/>
+                        <a:t>白佳煜</a:t>
+                      </a:r>
+                    </a:p>
+                  </a:txBody>
+                  <a:tcPr>
+                    <a:lnL w="12700" cap="flat" cmpd="sng" algn="ctr">
+                      <a:solidFill>
+                        <a:schemeClr val="tx1"/>
+                      </a:solidFill>
+                      <a:prstDash val="solid"/>
+                      <a:round/>
+                      <a:headEnd type="none" w="med" len="med"/>
+                      <a:tailEnd type="none" w="med" len="med"/>
+                    </a:lnL>
+                    <a:lnR w="12700" cap="flat" cmpd="sng" algn="ctr">
+                      <a:solidFill>
+                        <a:schemeClr val="tx1"/>
+                      </a:solidFill>
+                      <a:prstDash val="solid"/>
+                      <a:round/>
+                      <a:headEnd type="none" w="med" len="med"/>
+                      <a:tailEnd type="none" w="med" len="med"/>
+                    </a:lnR>
+                    <a:lnT w="12700" cap="flat" cmpd="sng" algn="ctr">
+                      <a:solidFill>
+                        <a:schemeClr val="tx1"/>
+                      </a:solidFill>
+                      <a:prstDash val="solid"/>
+                      <a:round/>
+                      <a:headEnd type="none" w="med" len="med"/>
+                      <a:tailEnd type="none" w="med" len="med"/>
+                    </a:lnT>
+                    <a:lnB w="12700" cap="flat" cmpd="sng" algn="ctr">
+                      <a:solidFill>
+                        <a:schemeClr val="tx1"/>
+                      </a:solidFill>
+                      <a:prstDash val="solid"/>
+                      <a:round/>
+                      <a:headEnd type="none" w="med" len="med"/>
+                      <a:tailEnd type="none" w="med" len="med"/>
+                    </a:lnB>
+                    <a:lnTlToBr w="12700" cmpd="sng">
+                      <a:noFill/>
+                      <a:prstDash val="solid"/>
+                    </a:lnTlToBr>
+                    <a:lnBlToTr w="12700" cmpd="sng">
+                      <a:noFill/>
+                      <a:prstDash val="solid"/>
+                    </a:lnBlToTr>
+                  </a:tcPr>
+                </a:tc>
+                <a:tc>
+                  <a:txBody>
+                    <a:bodyPr/>
+                    <a:lstStyle/>
+                    <a:p>
+                      <a:r>
+                        <a:rPr lang="zh-CN" altLang="en-US" sz="1600" dirty="0"/>
+                        <a:t>汇报撰写、</a:t>
+                      </a:r>
+                      <a:r>
+                        <a:rPr lang="en-US" altLang="zh-CN" sz="1600" dirty="0"/>
+                        <a:t>PPT</a:t>
+                      </a:r>
+                      <a:r>
+                        <a:rPr lang="zh-CN" altLang="en-US" sz="1600" dirty="0"/>
+                        <a:t>制作</a:t>
+                      </a:r>
+                    </a:p>
+                  </a:txBody>
+                  <a:tcPr>
+                    <a:lnL w="12700" cap="flat" cmpd="sng" algn="ctr">
+                      <a:solidFill>
+                        <a:schemeClr val="tx1"/>
+                      </a:solidFill>
+                      <a:prstDash val="solid"/>
+                      <a:round/>
+                      <a:headEnd type="none" w="med" len="med"/>
+                      <a:tailEnd type="none" w="med" len="med"/>
+                    </a:lnL>
+                    <a:lnR w="12700" cap="flat" cmpd="sng" algn="ctr">
+                      <a:solidFill>
+                        <a:schemeClr val="tx1"/>
+                      </a:solidFill>
+                      <a:prstDash val="solid"/>
+                      <a:round/>
+                      <a:headEnd type="none" w="med" len="med"/>
+                      <a:tailEnd type="none" w="med" len="med"/>
+                    </a:lnR>
+                    <a:lnT w="12700" cap="flat" cmpd="sng" algn="ctr">
+                      <a:solidFill>
+                        <a:schemeClr val="tx1"/>
+                      </a:solidFill>
+                      <a:prstDash val="solid"/>
+                      <a:round/>
+                      <a:headEnd type="none" w="med" len="med"/>
+                      <a:tailEnd type="none" w="med" len="med"/>
+                    </a:lnT>
+                    <a:lnB w="12700" cap="flat" cmpd="sng" algn="ctr">
+                      <a:solidFill>
+                        <a:schemeClr val="tx1"/>
+                      </a:solidFill>
+                      <a:prstDash val="solid"/>
+                      <a:round/>
+                      <a:headEnd type="none" w="med" len="med"/>
+                      <a:tailEnd type="none" w="med" len="med"/>
+                    </a:lnB>
+                  </a:tcPr>
+                </a:tc>
+                <a:extLst>
+                  <a:ext uri="{0D108BD9-81ED-4DB2-BD59-A6C34878D82A}">
+                    <a16:rowId xmlns:a16="http://schemas.microsoft.com/office/drawing/2014/main" val="2761756179"/>
+                  </a:ext>
+                </a:extLst>
+              </a:tr>
+              <a:tr h="405624">
+                <a:tc>
+                  <a:txBody>
+                    <a:bodyPr/>
+                    <a:lstStyle/>
+                    <a:p>
+                      <a:r>
+                        <a:rPr lang="zh-CN" altLang="en-US" dirty="0"/>
+                        <a:t>胡桥健</a:t>
+                      </a:r>
+                    </a:p>
+                  </a:txBody>
+                  <a:tcPr>
+                    <a:lnL w="12700" cap="flat" cmpd="sng" algn="ctr">
+                      <a:solidFill>
+                        <a:schemeClr val="tx1"/>
+                      </a:solidFill>
+                      <a:prstDash val="solid"/>
+                      <a:round/>
+                      <a:headEnd type="none" w="med" len="med"/>
+                      <a:tailEnd type="none" w="med" len="med"/>
+                    </a:lnL>
+                    <a:lnR w="12700" cap="flat" cmpd="sng" algn="ctr">
+                      <a:solidFill>
+                        <a:schemeClr val="tx1"/>
+                      </a:solidFill>
+                      <a:prstDash val="solid"/>
+                      <a:round/>
+                      <a:headEnd type="none" w="med" len="med"/>
+                      <a:tailEnd type="none" w="med" len="med"/>
+                    </a:lnR>
+                    <a:lnT w="12700" cap="flat" cmpd="sng" algn="ctr">
+                      <a:solidFill>
+                        <a:schemeClr val="tx1"/>
+                      </a:solidFill>
+                      <a:prstDash val="solid"/>
+                      <a:round/>
+                      <a:headEnd type="none" w="med" len="med"/>
+                      <a:tailEnd type="none" w="med" len="med"/>
+                    </a:lnT>
+                    <a:lnB w="12700" cap="flat" cmpd="sng" algn="ctr">
+                      <a:solidFill>
+                        <a:schemeClr val="tx1"/>
+                      </a:solidFill>
+                      <a:prstDash val="solid"/>
+                      <a:round/>
+                      <a:headEnd type="none" w="med" len="med"/>
+                      <a:tailEnd type="none" w="med" len="med"/>
+                    </a:lnB>
+                  </a:tcPr>
+                </a:tc>
+                <a:tc>
+                  <a:txBody>
+                    <a:bodyPr/>
+                    <a:lstStyle/>
+                    <a:p>
+                      <a:r>
+                        <a:rPr lang="zh-CN" altLang="en-US" sz="1600" dirty="0"/>
+                        <a:t>前端功能开发、项目测试</a:t>
+                      </a:r>
+                    </a:p>
+                  </a:txBody>
+                  <a:tcPr>
+                    <a:lnL w="12700" cap="flat" cmpd="sng" algn="ctr">
+                      <a:solidFill>
+                        <a:schemeClr val="tx1"/>
+                      </a:solidFill>
+                      <a:prstDash val="solid"/>
+                      <a:round/>
+                      <a:headEnd type="none" w="med" len="med"/>
+                      <a:tailEnd type="none" w="med" len="med"/>
+                    </a:lnL>
+                    <a:lnR w="12700" cap="flat" cmpd="sng" algn="ctr">
+                      <a:solidFill>
+                        <a:schemeClr val="tx1"/>
+                      </a:solidFill>
+                      <a:prstDash val="solid"/>
+                      <a:round/>
+                      <a:headEnd type="none" w="med" len="med"/>
+                      <a:tailEnd type="none" w="med" len="med"/>
+                    </a:lnR>
+                    <a:lnT w="12700" cap="flat" cmpd="sng" algn="ctr">
+                      <a:solidFill>
+                        <a:schemeClr val="tx1"/>
+                      </a:solidFill>
+                      <a:prstDash val="solid"/>
+                      <a:round/>
+                      <a:headEnd type="none" w="med" len="med"/>
+                      <a:tailEnd type="none" w="med" len="med"/>
+                    </a:lnT>
+                    <a:lnB w="12700" cap="flat" cmpd="sng" algn="ctr">
+                      <a:solidFill>
+                        <a:schemeClr val="tx1"/>
+                      </a:solidFill>
+                      <a:prstDash val="solid"/>
+                      <a:round/>
+                      <a:headEnd type="none" w="med" len="med"/>
+                      <a:tailEnd type="none" w="med" len="med"/>
+                    </a:lnB>
+                  </a:tcPr>
+                </a:tc>
+                <a:extLst>
+                  <a:ext uri="{0D108BD9-81ED-4DB2-BD59-A6C34878D82A}">
+                    <a16:rowId xmlns:a16="http://schemas.microsoft.com/office/drawing/2014/main" val="847884809"/>
+                  </a:ext>
+                </a:extLst>
+              </a:tr>
+              <a:tr h="405624">
+                <a:tc>
+                  <a:txBody>
+                    <a:bodyPr/>
+                    <a:lstStyle/>
+                    <a:p>
+                      <a:r>
+                        <a:rPr lang="zh-CN" altLang="en-US" dirty="0"/>
+                        <a:t>庄子硕</a:t>
+                      </a:r>
+                    </a:p>
+                  </a:txBody>
+                  <a:tcPr>
+                    <a:lnL w="12700" cap="flat" cmpd="sng" algn="ctr">
+                      <a:solidFill>
+                        <a:schemeClr val="tx1"/>
+                      </a:solidFill>
+                      <a:prstDash val="solid"/>
+                      <a:round/>
+                      <a:headEnd type="none" w="med" len="med"/>
+                      <a:tailEnd type="none" w="med" len="med"/>
+                    </a:lnL>
+                    <a:lnR w="12700" cap="flat" cmpd="sng" algn="ctr">
+                      <a:solidFill>
+                        <a:schemeClr val="tx1"/>
+                      </a:solidFill>
+                      <a:prstDash val="solid"/>
+                      <a:round/>
+                      <a:headEnd type="none" w="med" len="med"/>
+                      <a:tailEnd type="none" w="med" len="med"/>
+                    </a:lnR>
+                    <a:lnT w="12700" cap="flat" cmpd="sng" algn="ctr">
+                      <a:solidFill>
+                        <a:schemeClr val="tx1"/>
+                      </a:solidFill>
+                      <a:prstDash val="solid"/>
+                      <a:round/>
+                      <a:headEnd type="none" w="med" len="med"/>
+                      <a:tailEnd type="none" w="med" len="med"/>
+                    </a:lnT>
+                    <a:lnB w="12700" cap="flat" cmpd="sng" algn="ctr">
+                      <a:solidFill>
+                        <a:schemeClr val="tx1"/>
+                      </a:solidFill>
+                      <a:prstDash val="solid"/>
+                      <a:round/>
+                      <a:headEnd type="none" w="med" len="med"/>
+                      <a:tailEnd type="none" w="med" len="med"/>
+                    </a:lnB>
+                  </a:tcPr>
+                </a:tc>
+                <a:tc>
+                  <a:txBody>
+                    <a:bodyPr/>
+                    <a:lstStyle/>
+                    <a:p>
+                      <a:r>
+                        <a:rPr lang="zh-CN" altLang="en-US" sz="1600" dirty="0"/>
+                        <a:t>词法</a:t>
+                      </a:r>
+                      <a:r>
+                        <a:rPr lang="en-US" altLang="zh-CN" sz="1600" dirty="0"/>
+                        <a:t>+</a:t>
+                      </a:r>
+                      <a:r>
+                        <a:rPr lang="zh-CN" altLang="en-US" sz="1600" dirty="0"/>
+                        <a:t>语法分析器开发</a:t>
+                      </a:r>
+                    </a:p>
+                  </a:txBody>
+                  <a:tcPr>
+                    <a:lnL w="12700" cap="flat" cmpd="sng" algn="ctr">
+                      <a:solidFill>
+                        <a:schemeClr val="tx1"/>
+                      </a:solidFill>
+                      <a:prstDash val="solid"/>
+                      <a:round/>
+                      <a:headEnd type="none" w="med" len="med"/>
+                      <a:tailEnd type="none" w="med" len="med"/>
+                    </a:lnL>
+                    <a:lnR w="12700" cap="flat" cmpd="sng" algn="ctr">
+                      <a:solidFill>
+                        <a:schemeClr val="tx1"/>
+                      </a:solidFill>
+                      <a:prstDash val="solid"/>
+                      <a:round/>
+                      <a:headEnd type="none" w="med" len="med"/>
+                      <a:tailEnd type="none" w="med" len="med"/>
+                    </a:lnR>
+                    <a:lnT w="12700" cap="flat" cmpd="sng" algn="ctr">
+                      <a:solidFill>
+                        <a:schemeClr val="tx1"/>
+                      </a:solidFill>
+                      <a:prstDash val="solid"/>
+                      <a:round/>
+                      <a:headEnd type="none" w="med" len="med"/>
+                      <a:tailEnd type="none" w="med" len="med"/>
+                    </a:lnT>
+                    <a:lnB w="12700" cap="flat" cmpd="sng" algn="ctr">
+                      <a:solidFill>
+                        <a:schemeClr val="tx1"/>
+                      </a:solidFill>
+                      <a:prstDash val="solid"/>
+                      <a:round/>
+                      <a:headEnd type="none" w="med" len="med"/>
+                      <a:tailEnd type="none" w="med" len="med"/>
+                    </a:lnB>
+                  </a:tcPr>
+                </a:tc>
+                <a:extLst>
+                  <a:ext uri="{0D108BD9-81ED-4DB2-BD59-A6C34878D82A}">
+                    <a16:rowId xmlns:a16="http://schemas.microsoft.com/office/drawing/2014/main" val="3743239892"/>
+                  </a:ext>
+                </a:extLst>
+              </a:tr>
+            </a:tbl>
+          </a:graphicData>
+        </a:graphic>
+      </p:graphicFrame>
     </p:spTree>
   </p:cSld>
   <p:clrMapOvr>

</xml_diff>